<commit_message>
Revert "chore: update presentation files for TicTacToe activity"
This reverts commit 5d7b7de4cb69846bb4e1b8ddb6c4250d4dc7e425.
</commit_message>
<xml_diff>
--- a/apresentacao/Exercicio Mastery Aware Pipeline - TicTacToe.pptx
+++ b/apresentacao/Exercicio Mastery Aware Pipeline - TicTacToe.pptx
@@ -16,8 +16,8 @@
     <p:sldId id="838" r:id="rId7"/>
     <p:sldId id="839" r:id="rId8"/>
     <p:sldId id="840" r:id="rId9"/>
-    <p:sldId id="811" r:id="rId10"/>
-    <p:sldId id="809" r:id="rId11"/>
+    <p:sldId id="809" r:id="rId10"/>
+    <p:sldId id="811" r:id="rId11"/>
     <p:sldId id="812" r:id="rId12"/>
     <p:sldId id="818" r:id="rId13"/>
     <p:sldId id="819" r:id="rId14"/>
@@ -931,7 +931,7 @@
         <p:cNvPr id="1" name="Shape 388">
           <a:extLst>
             <a:ext uri="{FF2B5EF4-FFF2-40B4-BE49-F238E27FC236}">
-              <a16:creationId xmlns:a16="http://schemas.microsoft.com/office/drawing/2014/main" id="{174662B5-4732-7532-0D7C-61F1A5A2994C}"/>
+              <a16:creationId xmlns:a16="http://schemas.microsoft.com/office/drawing/2014/main" id="{93653752-2D3C-D193-FE3C-7B14EA378876}"/>
             </a:ext>
           </a:extLst>
         </p:cNvPr>
@@ -951,7 +951,7 @@
           <p:cNvPr id="389" name="Google Shape;389;g2f4e53b8aae_0_20:notes">
             <a:extLst>
               <a:ext uri="{FF2B5EF4-FFF2-40B4-BE49-F238E27FC236}">
-                <a16:creationId xmlns:a16="http://schemas.microsoft.com/office/drawing/2014/main" id="{F1CD7E32-2F0E-43C2-8F2D-A0D42A2B20C0}"/>
+                <a16:creationId xmlns:a16="http://schemas.microsoft.com/office/drawing/2014/main" id="{74B67C1F-20D0-9F76-325E-7D1DF16B6A3B}"/>
               </a:ext>
             </a:extLst>
           </p:cNvPr>
@@ -998,7 +998,7 @@
           <p:cNvPr id="390" name="Google Shape;390;g2f4e53b8aae_0_20:notes">
             <a:extLst>
               <a:ext uri="{FF2B5EF4-FFF2-40B4-BE49-F238E27FC236}">
-                <a16:creationId xmlns:a16="http://schemas.microsoft.com/office/drawing/2014/main" id="{FA2C38C8-C7C5-2145-7C0E-A903C874AA53}"/>
+                <a16:creationId xmlns:a16="http://schemas.microsoft.com/office/drawing/2014/main" id="{9B5AFFB9-FCAF-46B1-10B6-7E9DA7C99D97}"/>
               </a:ext>
             </a:extLst>
           </p:cNvPr>
@@ -1040,7 +1040,7 @@
     </p:spTree>
     <p:extLst>
       <p:ext uri="{BB962C8B-B14F-4D97-AF65-F5344CB8AC3E}">
-        <p14:creationId xmlns:p14="http://schemas.microsoft.com/office/powerpoint/2010/main" val="3554557918"/>
+        <p14:creationId xmlns:p14="http://schemas.microsoft.com/office/powerpoint/2010/main" val="2962722091"/>
       </p:ext>
     </p:extLst>
   </p:cSld>
@@ -3217,7 +3217,7 @@
         <p:cNvPr id="1" name="Shape 388">
           <a:extLst>
             <a:ext uri="{FF2B5EF4-FFF2-40B4-BE49-F238E27FC236}">
-              <a16:creationId xmlns:a16="http://schemas.microsoft.com/office/drawing/2014/main" id="{93653752-2D3C-D193-FE3C-7B14EA378876}"/>
+              <a16:creationId xmlns:a16="http://schemas.microsoft.com/office/drawing/2014/main" id="{174662B5-4732-7532-0D7C-61F1A5A2994C}"/>
             </a:ext>
           </a:extLst>
         </p:cNvPr>
@@ -3237,7 +3237,7 @@
           <p:cNvPr id="389" name="Google Shape;389;g2f4e53b8aae_0_20:notes">
             <a:extLst>
               <a:ext uri="{FF2B5EF4-FFF2-40B4-BE49-F238E27FC236}">
-                <a16:creationId xmlns:a16="http://schemas.microsoft.com/office/drawing/2014/main" id="{74B67C1F-20D0-9F76-325E-7D1DF16B6A3B}"/>
+                <a16:creationId xmlns:a16="http://schemas.microsoft.com/office/drawing/2014/main" id="{F1CD7E32-2F0E-43C2-8F2D-A0D42A2B20C0}"/>
               </a:ext>
             </a:extLst>
           </p:cNvPr>
@@ -3284,7 +3284,7 @@
           <p:cNvPr id="390" name="Google Shape;390;g2f4e53b8aae_0_20:notes">
             <a:extLst>
               <a:ext uri="{FF2B5EF4-FFF2-40B4-BE49-F238E27FC236}">
-                <a16:creationId xmlns:a16="http://schemas.microsoft.com/office/drawing/2014/main" id="{9B5AFFB9-FCAF-46B1-10B6-7E9DA7C99D97}"/>
+                <a16:creationId xmlns:a16="http://schemas.microsoft.com/office/drawing/2014/main" id="{FA2C38C8-C7C5-2145-7C0E-A903C874AA53}"/>
               </a:ext>
             </a:extLst>
           </p:cNvPr>
@@ -3326,7 +3326,7 @@
     </p:spTree>
     <p:extLst>
       <p:ext uri="{BB962C8B-B14F-4D97-AF65-F5344CB8AC3E}">
-        <p14:creationId xmlns:p14="http://schemas.microsoft.com/office/powerpoint/2010/main" val="2962722091"/>
+        <p14:creationId xmlns:p14="http://schemas.microsoft.com/office/powerpoint/2010/main" val="3554557918"/>
       </p:ext>
     </p:extLst>
   </p:cSld>
@@ -18097,7 +18097,7 @@
         <p:cNvPr id="1" name="Shape 391">
           <a:extLst>
             <a:ext uri="{FF2B5EF4-FFF2-40B4-BE49-F238E27FC236}">
-              <a16:creationId xmlns:a16="http://schemas.microsoft.com/office/drawing/2014/main" id="{3BADABB6-0DB8-E1AD-73E7-6C322CDB16EA}"/>
+              <a16:creationId xmlns:a16="http://schemas.microsoft.com/office/drawing/2014/main" id="{C821203B-07C1-CEE1-C9E2-E07D6B8DB18C}"/>
             </a:ext>
           </a:extLst>
         </p:cNvPr>
@@ -18117,7 +18117,7 @@
           <p:cNvPr id="4" name="Picture 3">
             <a:extLst>
               <a:ext uri="{FF2B5EF4-FFF2-40B4-BE49-F238E27FC236}">
-                <a16:creationId xmlns:a16="http://schemas.microsoft.com/office/drawing/2014/main" id="{ADE1A46C-A140-F000-0A6D-B9445672E0C5}"/>
+                <a16:creationId xmlns:a16="http://schemas.microsoft.com/office/drawing/2014/main" id="{5BDA9E17-6C2C-C1CE-2D9A-252D42B3B2D8}"/>
               </a:ext>
             </a:extLst>
           </p:cNvPr>
@@ -18134,12 +18134,17 @@
         </p:blipFill>
         <p:spPr>
           <a:xfrm>
-            <a:off x="533400" y="641730"/>
-            <a:ext cx="7467600" cy="4013835"/>
+            <a:off x="2296433" y="678878"/>
+            <a:ext cx="4551134" cy="3939540"/>
           </a:xfrm>
           <a:prstGeom prst="rect">
             <a:avLst/>
           </a:prstGeom>
+          <a:ln>
+            <a:solidFill>
+              <a:schemeClr val="tx1"/>
+            </a:solidFill>
+          </a:ln>
         </p:spPr>
       </p:pic>
       <p:sp>
@@ -18147,7 +18152,7 @@
           <p:cNvPr id="392" name="Google Shape;392;p41">
             <a:extLst>
               <a:ext uri="{FF2B5EF4-FFF2-40B4-BE49-F238E27FC236}">
-                <a16:creationId xmlns:a16="http://schemas.microsoft.com/office/drawing/2014/main" id="{8E8406D4-117A-9419-3621-C738B7C06FE4}"/>
+                <a16:creationId xmlns:a16="http://schemas.microsoft.com/office/drawing/2014/main" id="{79B4BB56-F43A-A6AA-F988-6A8DC7040918}"/>
               </a:ext>
             </a:extLst>
           </p:cNvPr>
@@ -18207,7 +18212,7 @@
           <p:cNvPr id="5" name="TextBox 4">
             <a:extLst>
               <a:ext uri="{FF2B5EF4-FFF2-40B4-BE49-F238E27FC236}">
-                <a16:creationId xmlns:a16="http://schemas.microsoft.com/office/drawing/2014/main" id="{E90AB356-A848-4113-E0D1-F6F1984488CE}"/>
+                <a16:creationId xmlns:a16="http://schemas.microsoft.com/office/drawing/2014/main" id="{1D466ACB-B9C2-A45F-0E67-16CD0E7E93E6}"/>
               </a:ext>
             </a:extLst>
           </p:cNvPr>
@@ -18216,8 +18221,8 @@
         </p:nvSpPr>
         <p:spPr>
           <a:xfrm>
-            <a:off x="4447552" y="4753562"/>
-            <a:ext cx="4572000" cy="307777"/>
+            <a:off x="2296433" y="4724171"/>
+            <a:ext cx="6634207" cy="307777"/>
           </a:xfrm>
           <a:prstGeom prst="rect">
             <a:avLst/>
@@ -18234,68 +18239,16 @@
               <a:rPr lang="en-GB" dirty="0">
                 <a:hlinkClick r:id="rId4"/>
               </a:rPr>
-              <a:t>https://github.com/IsabelaYabe/tictactoe_activity_ai</a:t>
+              <a:t>https://github.com/IsabelaYabe/tictactoe_activity_ai/blob/master/README.md</a:t>
             </a:r>
             <a:endParaRPr lang="en-GB" dirty="0"/>
-          </a:p>
-        </p:txBody>
-      </p:sp>
-      <p:sp>
-        <p:nvSpPr>
-          <p:cNvPr id="8" name="Rectangle 7">
-            <a:extLst>
-              <a:ext uri="{FF2B5EF4-FFF2-40B4-BE49-F238E27FC236}">
-                <a16:creationId xmlns:a16="http://schemas.microsoft.com/office/drawing/2014/main" id="{11E45327-5832-674B-014F-7DEB2CE30971}"/>
-              </a:ext>
-            </a:extLst>
-          </p:cNvPr>
-          <p:cNvSpPr/>
-          <p:nvPr/>
-        </p:nvSpPr>
-        <p:spPr>
-          <a:xfrm>
-            <a:off x="5530850" y="1348740"/>
-            <a:ext cx="446617" cy="187960"/>
-          </a:xfrm>
-          <a:prstGeom prst="rect">
-            <a:avLst/>
-          </a:prstGeom>
-          <a:noFill/>
-          <a:ln>
-            <a:solidFill>
-              <a:srgbClr val="0070C0"/>
-            </a:solidFill>
-          </a:ln>
-        </p:spPr>
-        <p:style>
-          <a:lnRef idx="2">
-            <a:schemeClr val="accent1">
-              <a:shade val="15000"/>
-            </a:schemeClr>
-          </a:lnRef>
-          <a:fillRef idx="1">
-            <a:schemeClr val="accent1"/>
-          </a:fillRef>
-          <a:effectRef idx="0">
-            <a:schemeClr val="accent1"/>
-          </a:effectRef>
-          <a:fontRef idx="minor">
-            <a:schemeClr val="lt1"/>
-          </a:fontRef>
-        </p:style>
-        <p:txBody>
-          <a:bodyPr rtlCol="0" anchor="ctr"/>
-          <a:lstStyle/>
-          <a:p>
-            <a:pPr algn="ctr"/>
-            <a:endParaRPr lang="en-GB"/>
           </a:p>
         </p:txBody>
       </p:sp>
     </p:spTree>
     <p:extLst>
       <p:ext uri="{BB962C8B-B14F-4D97-AF65-F5344CB8AC3E}">
-        <p14:creationId xmlns:p14="http://schemas.microsoft.com/office/powerpoint/2010/main" val="4207120361"/>
+        <p14:creationId xmlns:p14="http://schemas.microsoft.com/office/powerpoint/2010/main" val="387037970"/>
       </p:ext>
     </p:extLst>
   </p:cSld>
@@ -28043,6 +27996,66 @@
           <a:p>
             <a:pPr algn="ctr"/>
             <a:endParaRPr lang="en-GB"/>
+          </a:p>
+        </p:txBody>
+      </p:sp>
+      <p:sp>
+        <p:nvSpPr>
+          <p:cNvPr id="8" name="TextBox 7">
+            <a:extLst>
+              <a:ext uri="{FF2B5EF4-FFF2-40B4-BE49-F238E27FC236}">
+                <a16:creationId xmlns:a16="http://schemas.microsoft.com/office/drawing/2014/main" id="{304DD983-E824-A37B-CD33-A18BA648A460}"/>
+              </a:ext>
+            </a:extLst>
+          </p:cNvPr>
+          <p:cNvSpPr txBox="1"/>
+          <p:nvPr/>
+        </p:nvSpPr>
+        <p:spPr>
+          <a:xfrm>
+            <a:off x="6055282" y="1302428"/>
+            <a:ext cx="1870681" cy="215444"/>
+          </a:xfrm>
+          <a:prstGeom prst="rect">
+            <a:avLst/>
+          </a:prstGeom>
+          <a:noFill/>
+        </p:spPr>
+        <p:txBody>
+          <a:bodyPr wrap="square" rtlCol="0">
+            <a:spAutoFit/>
+          </a:bodyPr>
+          <a:lstStyle/>
+          <a:p>
+            <a:r>
+              <a:rPr lang="en-US" sz="800" dirty="0"/>
+              <a:t>*É a </a:t>
+            </a:r>
+            <a:r>
+              <a:rPr lang="en-US" sz="800" dirty="0" err="1"/>
+              <a:t>mesma</a:t>
+            </a:r>
+            <a:r>
+              <a:rPr lang="en-US" sz="800" dirty="0"/>
+              <a:t> </a:t>
+            </a:r>
+            <a:r>
+              <a:rPr lang="en-US" sz="800" dirty="0" err="1"/>
+              <a:t>chave</a:t>
+            </a:r>
+            <a:r>
+              <a:rPr lang="en-US" sz="800" dirty="0"/>
+              <a:t> do </a:t>
+            </a:r>
+            <a:r>
+              <a:rPr lang="en-US" sz="800" dirty="0" err="1"/>
+              <a:t>arquivo</a:t>
+            </a:r>
+            <a:r>
+              <a:rPr lang="en-US" sz="800" dirty="0"/>
+              <a:t> .env</a:t>
+            </a:r>
+            <a:endParaRPr lang="en-GB" sz="800" dirty="0"/>
           </a:p>
         </p:txBody>
       </p:sp>
@@ -28894,6 +28907,114 @@
       </p:sp>
       <p:sp>
         <p:nvSpPr>
+          <p:cNvPr id="5" name="Arrow: Right 4">
+            <a:extLst>
+              <a:ext uri="{FF2B5EF4-FFF2-40B4-BE49-F238E27FC236}">
+                <a16:creationId xmlns:a16="http://schemas.microsoft.com/office/drawing/2014/main" id="{C4364147-6374-F52A-87B2-AFF4812B59C7}"/>
+              </a:ext>
+            </a:extLst>
+          </p:cNvPr>
+          <p:cNvSpPr/>
+          <p:nvPr/>
+        </p:nvSpPr>
+        <p:spPr>
+          <a:xfrm flipH="1">
+            <a:off x="6988380" y="4909250"/>
+            <a:ext cx="213595" cy="194225"/>
+          </a:xfrm>
+          <a:prstGeom prst="rightArrow">
+            <a:avLst/>
+          </a:prstGeom>
+          <a:solidFill>
+            <a:srgbClr val="FFFF00"/>
+          </a:solidFill>
+          <a:ln>
+            <a:solidFill>
+              <a:schemeClr val="tx1"/>
+            </a:solidFill>
+          </a:ln>
+        </p:spPr>
+        <p:style>
+          <a:lnRef idx="2">
+            <a:schemeClr val="accent1">
+              <a:shade val="15000"/>
+            </a:schemeClr>
+          </a:lnRef>
+          <a:fillRef idx="1">
+            <a:schemeClr val="accent1"/>
+          </a:fillRef>
+          <a:effectRef idx="0">
+            <a:schemeClr val="accent1"/>
+          </a:effectRef>
+          <a:fontRef idx="minor">
+            <a:schemeClr val="lt1"/>
+          </a:fontRef>
+        </p:style>
+        <p:txBody>
+          <a:bodyPr rtlCol="0" anchor="ctr"/>
+          <a:lstStyle/>
+          <a:p>
+            <a:pPr algn="ctr"/>
+            <a:endParaRPr lang="en-GB"/>
+          </a:p>
+        </p:txBody>
+      </p:sp>
+      <p:sp>
+        <p:nvSpPr>
+          <p:cNvPr id="9" name="Arrow: Right 8">
+            <a:extLst>
+              <a:ext uri="{FF2B5EF4-FFF2-40B4-BE49-F238E27FC236}">
+                <a16:creationId xmlns:a16="http://schemas.microsoft.com/office/drawing/2014/main" id="{397FCC05-C979-0BC9-50FA-0ECD955BEC94}"/>
+              </a:ext>
+            </a:extLst>
+          </p:cNvPr>
+          <p:cNvSpPr/>
+          <p:nvPr/>
+        </p:nvSpPr>
+        <p:spPr>
+          <a:xfrm rot="10800000" flipH="1">
+            <a:off x="6122076" y="4780028"/>
+            <a:ext cx="213595" cy="194225"/>
+          </a:xfrm>
+          <a:prstGeom prst="rightArrow">
+            <a:avLst/>
+          </a:prstGeom>
+          <a:solidFill>
+            <a:srgbClr val="FFFF00"/>
+          </a:solidFill>
+          <a:ln>
+            <a:solidFill>
+              <a:schemeClr val="tx1"/>
+            </a:solidFill>
+          </a:ln>
+        </p:spPr>
+        <p:style>
+          <a:lnRef idx="2">
+            <a:schemeClr val="accent1">
+              <a:shade val="15000"/>
+            </a:schemeClr>
+          </a:lnRef>
+          <a:fillRef idx="1">
+            <a:schemeClr val="accent1"/>
+          </a:fillRef>
+          <a:effectRef idx="0">
+            <a:schemeClr val="accent1"/>
+          </a:effectRef>
+          <a:fontRef idx="minor">
+            <a:schemeClr val="lt1"/>
+          </a:fontRef>
+        </p:style>
+        <p:txBody>
+          <a:bodyPr rtlCol="0" anchor="ctr"/>
+          <a:lstStyle/>
+          <a:p>
+            <a:pPr algn="ctr"/>
+            <a:endParaRPr lang="en-GB"/>
+          </a:p>
+        </p:txBody>
+      </p:sp>
+      <p:sp>
+        <p:nvSpPr>
           <p:cNvPr id="10" name="Rectangle 9">
             <a:extLst>
               <a:ext uri="{FF2B5EF4-FFF2-40B4-BE49-F238E27FC236}">
@@ -28977,12 +29098,168 @@
           </a:p>
         </p:txBody>
       </p:sp>
+    </p:spTree>
+    <p:extLst>
+      <p:ext uri="{BB962C8B-B14F-4D97-AF65-F5344CB8AC3E}">
+        <p14:creationId xmlns:p14="http://schemas.microsoft.com/office/powerpoint/2010/main" val="1520744038"/>
+      </p:ext>
+    </p:extLst>
+  </p:cSld>
+  <p:clrMapOvr>
+    <a:masterClrMapping/>
+  </p:clrMapOvr>
+</p:sld>
+</file>
+
+<file path=ppt/slides/slide9.xml><?xml version="1.0" encoding="utf-8"?>
+<p:sld xmlns:a="http://schemas.openxmlformats.org/drawingml/2006/main" xmlns:r="http://schemas.openxmlformats.org/officeDocument/2006/relationships" xmlns:p="http://schemas.openxmlformats.org/presentationml/2006/main">
+  <p:cSld>
+    <p:spTree>
+      <p:nvGrpSpPr>
+        <p:cNvPr id="1" name="Shape 391">
+          <a:extLst>
+            <a:ext uri="{FF2B5EF4-FFF2-40B4-BE49-F238E27FC236}">
+              <a16:creationId xmlns:a16="http://schemas.microsoft.com/office/drawing/2014/main" id="{3BADABB6-0DB8-E1AD-73E7-6C322CDB16EA}"/>
+            </a:ext>
+          </a:extLst>
+        </p:cNvPr>
+        <p:cNvGrpSpPr/>
+        <p:nvPr/>
+      </p:nvGrpSpPr>
+      <p:grpSpPr>
+        <a:xfrm>
+          <a:off x="0" y="0"/>
+          <a:ext cx="0" cy="0"/>
+          <a:chOff x="0" y="0"/>
+          <a:chExt cx="0" cy="0"/>
+        </a:xfrm>
+      </p:grpSpPr>
+      <p:pic>
+        <p:nvPicPr>
+          <p:cNvPr id="3" name="Picture 2">
+            <a:extLst>
+              <a:ext uri="{FF2B5EF4-FFF2-40B4-BE49-F238E27FC236}">
+                <a16:creationId xmlns:a16="http://schemas.microsoft.com/office/drawing/2014/main" id="{749C675E-AEF7-05B6-3719-AD3FAD125854}"/>
+              </a:ext>
+            </a:extLst>
+          </p:cNvPr>
+          <p:cNvPicPr>
+            <a:picLocks noChangeAspect="1"/>
+          </p:cNvPicPr>
+          <p:nvPr/>
+        </p:nvPicPr>
+        <p:blipFill>
+          <a:blip r:embed="rId3"/>
+          <a:stretch>
+            <a:fillRect/>
+          </a:stretch>
+        </p:blipFill>
+        <p:spPr>
+          <a:xfrm>
+            <a:off x="533400" y="641730"/>
+            <a:ext cx="7467600" cy="4013835"/>
+          </a:xfrm>
+          <a:prstGeom prst="rect">
+            <a:avLst/>
+          </a:prstGeom>
+        </p:spPr>
+      </p:pic>
       <p:sp>
         <p:nvSpPr>
-          <p:cNvPr id="9" name="Arrow: Right 8">
+          <p:cNvPr id="392" name="Google Shape;392;p41">
             <a:extLst>
               <a:ext uri="{FF2B5EF4-FFF2-40B4-BE49-F238E27FC236}">
-                <a16:creationId xmlns:a16="http://schemas.microsoft.com/office/drawing/2014/main" id="{397FCC05-C979-0BC9-50FA-0ECD955BEC94}"/>
+                <a16:creationId xmlns:a16="http://schemas.microsoft.com/office/drawing/2014/main" id="{8E8406D4-117A-9419-3621-C738B7C06FE4}"/>
+              </a:ext>
+            </a:extLst>
+          </p:cNvPr>
+          <p:cNvSpPr txBox="1">
+            <a:spLocks noGrp="1"/>
+          </p:cNvSpPr>
+          <p:nvPr>
+            <p:ph type="title"/>
+          </p:nvPr>
+        </p:nvSpPr>
+        <p:spPr>
+          <a:xfrm>
+            <a:off x="1117649" y="40025"/>
+            <a:ext cx="7220001" cy="533100"/>
+          </a:xfrm>
+          <a:prstGeom prst="rect">
+            <a:avLst/>
+          </a:prstGeom>
+        </p:spPr>
+        <p:txBody>
+          <a:bodyPr spcFirstLastPara="1" wrap="square" lIns="69850" tIns="34925" rIns="69850" bIns="34925" anchor="t" anchorCtr="0">
+            <a:normAutofit/>
+          </a:bodyPr>
+          <a:lstStyle/>
+          <a:p>
+            <a:pPr lvl="0"/>
+            <a:r>
+              <a:rPr lang="en-US" dirty="0"/>
+              <a:t>O </a:t>
+            </a:r>
+            <a:r>
+              <a:rPr lang="en-US" dirty="0" err="1"/>
+              <a:t>experimento</a:t>
+            </a:r>
+            <a:r>
+              <a:rPr lang="en-US" dirty="0"/>
+              <a:t>: </a:t>
+            </a:r>
+            <a:r>
+              <a:rPr lang="en-US" dirty="0" err="1"/>
+              <a:t>TicTacToe</a:t>
+            </a:r>
+            <a:endParaRPr dirty="0"/>
+          </a:p>
+        </p:txBody>
+      </p:sp>
+      <p:sp>
+        <p:nvSpPr>
+          <p:cNvPr id="5" name="TextBox 4">
+            <a:extLst>
+              <a:ext uri="{FF2B5EF4-FFF2-40B4-BE49-F238E27FC236}">
+                <a16:creationId xmlns:a16="http://schemas.microsoft.com/office/drawing/2014/main" id="{E90AB356-A848-4113-E0D1-F6F1984488CE}"/>
+              </a:ext>
+            </a:extLst>
+          </p:cNvPr>
+          <p:cNvSpPr txBox="1"/>
+          <p:nvPr/>
+        </p:nvSpPr>
+        <p:spPr>
+          <a:xfrm>
+            <a:off x="4447552" y="4753562"/>
+            <a:ext cx="4572000" cy="307777"/>
+          </a:xfrm>
+          <a:prstGeom prst="rect">
+            <a:avLst/>
+          </a:prstGeom>
+          <a:noFill/>
+        </p:spPr>
+        <p:txBody>
+          <a:bodyPr wrap="square">
+            <a:spAutoFit/>
+          </a:bodyPr>
+          <a:lstStyle/>
+          <a:p>
+            <a:r>
+              <a:rPr lang="en-GB" dirty="0">
+                <a:hlinkClick r:id="rId4"/>
+              </a:rPr>
+              <a:t>https://github.com/IsabelaYabe/tictactoe_activity_ai</a:t>
+            </a:r>
+            <a:endParaRPr lang="en-GB" dirty="0"/>
+          </a:p>
+        </p:txBody>
+      </p:sp>
+      <p:sp>
+        <p:nvSpPr>
+          <p:cNvPr id="8" name="Rectangle 7">
+            <a:extLst>
+              <a:ext uri="{FF2B5EF4-FFF2-40B4-BE49-F238E27FC236}">
+                <a16:creationId xmlns:a16="http://schemas.microsoft.com/office/drawing/2014/main" id="{11E45327-5832-674B-014F-7DEB2CE30971}"/>
               </a:ext>
             </a:extLst>
           </p:cNvPr>
@@ -28990,73 +29267,17 @@
           <p:nvPr/>
         </p:nvSpPr>
         <p:spPr>
-          <a:xfrm rot="10800000" flipH="1">
-            <a:off x="6122076" y="4780028"/>
-            <a:ext cx="213595" cy="194225"/>
+          <a:xfrm>
+            <a:off x="5494020" y="1348740"/>
+            <a:ext cx="595630" cy="251460"/>
           </a:xfrm>
-          <a:prstGeom prst="rightArrow">
+          <a:prstGeom prst="rect">
             <a:avLst/>
           </a:prstGeom>
-          <a:solidFill>
-            <a:srgbClr val="FFFF00"/>
-          </a:solidFill>
+          <a:noFill/>
           <a:ln>
             <a:solidFill>
-              <a:schemeClr val="tx1"/>
-            </a:solidFill>
-          </a:ln>
-        </p:spPr>
-        <p:style>
-          <a:lnRef idx="2">
-            <a:schemeClr val="accent1">
-              <a:shade val="15000"/>
-            </a:schemeClr>
-          </a:lnRef>
-          <a:fillRef idx="1">
-            <a:schemeClr val="accent1"/>
-          </a:fillRef>
-          <a:effectRef idx="0">
-            <a:schemeClr val="accent1"/>
-          </a:effectRef>
-          <a:fontRef idx="minor">
-            <a:schemeClr val="lt1"/>
-          </a:fontRef>
-        </p:style>
-        <p:txBody>
-          <a:bodyPr rtlCol="0" anchor="ctr"/>
-          <a:lstStyle/>
-          <a:p>
-            <a:pPr algn="ctr"/>
-            <a:endParaRPr lang="en-GB"/>
-          </a:p>
-        </p:txBody>
-      </p:sp>
-      <p:sp>
-        <p:nvSpPr>
-          <p:cNvPr id="5" name="Arrow: Right 4">
-            <a:extLst>
-              <a:ext uri="{FF2B5EF4-FFF2-40B4-BE49-F238E27FC236}">
-                <a16:creationId xmlns:a16="http://schemas.microsoft.com/office/drawing/2014/main" id="{C4364147-6374-F52A-87B2-AFF4812B59C7}"/>
-              </a:ext>
-            </a:extLst>
-          </p:cNvPr>
-          <p:cNvSpPr/>
-          <p:nvPr/>
-        </p:nvSpPr>
-        <p:spPr>
-          <a:xfrm flipH="1">
-            <a:off x="6988380" y="4909250"/>
-            <a:ext cx="213595" cy="194225"/>
-          </a:xfrm>
-          <a:prstGeom prst="rightArrow">
-            <a:avLst/>
-          </a:prstGeom>
-          <a:solidFill>
-            <a:srgbClr val="FFFF00"/>
-          </a:solidFill>
-          <a:ln>
-            <a:solidFill>
-              <a:schemeClr val="tx1"/>
+              <a:srgbClr val="0070C0"/>
             </a:solidFill>
           </a:ln>
         </p:spPr>
@@ -29088,176 +29309,7 @@
     </p:spTree>
     <p:extLst>
       <p:ext uri="{BB962C8B-B14F-4D97-AF65-F5344CB8AC3E}">
-        <p14:creationId xmlns:p14="http://schemas.microsoft.com/office/powerpoint/2010/main" val="1520744038"/>
-      </p:ext>
-    </p:extLst>
-  </p:cSld>
-  <p:clrMapOvr>
-    <a:masterClrMapping/>
-  </p:clrMapOvr>
-</p:sld>
-</file>
-
-<file path=ppt/slides/slide9.xml><?xml version="1.0" encoding="utf-8"?>
-<p:sld xmlns:a="http://schemas.openxmlformats.org/drawingml/2006/main" xmlns:r="http://schemas.openxmlformats.org/officeDocument/2006/relationships" xmlns:p="http://schemas.openxmlformats.org/presentationml/2006/main">
-  <p:cSld>
-    <p:spTree>
-      <p:nvGrpSpPr>
-        <p:cNvPr id="1" name="Shape 391">
-          <a:extLst>
-            <a:ext uri="{FF2B5EF4-FFF2-40B4-BE49-F238E27FC236}">
-              <a16:creationId xmlns:a16="http://schemas.microsoft.com/office/drawing/2014/main" id="{C821203B-07C1-CEE1-C9E2-E07D6B8DB18C}"/>
-            </a:ext>
-          </a:extLst>
-        </p:cNvPr>
-        <p:cNvGrpSpPr/>
-        <p:nvPr/>
-      </p:nvGrpSpPr>
-      <p:grpSpPr>
-        <a:xfrm>
-          <a:off x="0" y="0"/>
-          <a:ext cx="0" cy="0"/>
-          <a:chOff x="0" y="0"/>
-          <a:chExt cx="0" cy="0"/>
-        </a:xfrm>
-      </p:grpSpPr>
-      <p:sp>
-        <p:nvSpPr>
-          <p:cNvPr id="392" name="Google Shape;392;p41">
-            <a:extLst>
-              <a:ext uri="{FF2B5EF4-FFF2-40B4-BE49-F238E27FC236}">
-                <a16:creationId xmlns:a16="http://schemas.microsoft.com/office/drawing/2014/main" id="{79B4BB56-F43A-A6AA-F988-6A8DC7040918}"/>
-              </a:ext>
-            </a:extLst>
-          </p:cNvPr>
-          <p:cNvSpPr txBox="1">
-            <a:spLocks noGrp="1"/>
-          </p:cNvSpPr>
-          <p:nvPr>
-            <p:ph type="title"/>
-          </p:nvPr>
-        </p:nvSpPr>
-        <p:spPr>
-          <a:xfrm>
-            <a:off x="1117649" y="40025"/>
-            <a:ext cx="7220001" cy="533100"/>
-          </a:xfrm>
-          <a:prstGeom prst="rect">
-            <a:avLst/>
-          </a:prstGeom>
-        </p:spPr>
-        <p:txBody>
-          <a:bodyPr spcFirstLastPara="1" wrap="square" lIns="69850" tIns="34925" rIns="69850" bIns="34925" anchor="t" anchorCtr="0">
-            <a:normAutofit/>
-          </a:bodyPr>
-          <a:lstStyle/>
-          <a:p>
-            <a:pPr lvl="0"/>
-            <a:r>
-              <a:rPr lang="en-US" dirty="0"/>
-              <a:t>O </a:t>
-            </a:r>
-            <a:r>
-              <a:rPr lang="en-US" dirty="0" err="1"/>
-              <a:t>experimento</a:t>
-            </a:r>
-            <a:r>
-              <a:rPr lang="en-US" dirty="0"/>
-              <a:t>: </a:t>
-            </a:r>
-            <a:r>
-              <a:rPr lang="en-US" dirty="0" err="1"/>
-              <a:t>TicTacToe</a:t>
-            </a:r>
-            <a:r>
-              <a:rPr lang="en-US" dirty="0"/>
-              <a:t> - </a:t>
-            </a:r>
-            <a:r>
-              <a:rPr lang="en-US" dirty="0" err="1"/>
-              <a:t>Instruções</a:t>
-            </a:r>
-            <a:endParaRPr dirty="0"/>
-          </a:p>
-        </p:txBody>
-      </p:sp>
-      <p:sp>
-        <p:nvSpPr>
-          <p:cNvPr id="5" name="TextBox 4">
-            <a:extLst>
-              <a:ext uri="{FF2B5EF4-FFF2-40B4-BE49-F238E27FC236}">
-                <a16:creationId xmlns:a16="http://schemas.microsoft.com/office/drawing/2014/main" id="{1D466ACB-B9C2-A45F-0E67-16CD0E7E93E6}"/>
-              </a:ext>
-            </a:extLst>
-          </p:cNvPr>
-          <p:cNvSpPr txBox="1"/>
-          <p:nvPr/>
-        </p:nvSpPr>
-        <p:spPr>
-          <a:xfrm>
-            <a:off x="2296433" y="4724171"/>
-            <a:ext cx="6634207" cy="307777"/>
-          </a:xfrm>
-          <a:prstGeom prst="rect">
-            <a:avLst/>
-          </a:prstGeom>
-          <a:noFill/>
-        </p:spPr>
-        <p:txBody>
-          <a:bodyPr wrap="square">
-            <a:spAutoFit/>
-          </a:bodyPr>
-          <a:lstStyle/>
-          <a:p>
-            <a:r>
-              <a:rPr lang="en-GB" dirty="0">
-                <a:hlinkClick r:id="rId3"/>
-              </a:rPr>
-              <a:t>https://github.com/IsabelaYabe/tictactoe_activity_ai/blob/master/README.md</a:t>
-            </a:r>
-            <a:endParaRPr lang="en-GB" dirty="0"/>
-          </a:p>
-        </p:txBody>
-      </p:sp>
-      <p:pic>
-        <p:nvPicPr>
-          <p:cNvPr id="3" name="Picture 2">
-            <a:extLst>
-              <a:ext uri="{FF2B5EF4-FFF2-40B4-BE49-F238E27FC236}">
-                <a16:creationId xmlns:a16="http://schemas.microsoft.com/office/drawing/2014/main" id="{C548D015-2DE6-9F74-39C0-345AFE5F6CB9}"/>
-              </a:ext>
-            </a:extLst>
-          </p:cNvPr>
-          <p:cNvPicPr>
-            <a:picLocks noChangeAspect="1"/>
-          </p:cNvPicPr>
-          <p:nvPr/>
-        </p:nvPicPr>
-        <p:blipFill>
-          <a:blip r:embed="rId4"/>
-          <a:stretch>
-            <a:fillRect/>
-          </a:stretch>
-        </p:blipFill>
-        <p:spPr>
-          <a:xfrm>
-            <a:off x="3085127" y="651596"/>
-            <a:ext cx="3285044" cy="3994103"/>
-          </a:xfrm>
-          <a:prstGeom prst="rect">
-            <a:avLst/>
-          </a:prstGeom>
-          <a:ln>
-            <a:solidFill>
-              <a:schemeClr val="tx1"/>
-            </a:solidFill>
-          </a:ln>
-        </p:spPr>
-      </p:pic>
-    </p:spTree>
-    <p:extLst>
-      <p:ext uri="{BB962C8B-B14F-4D97-AF65-F5344CB8AC3E}">
-        <p14:creationId xmlns:p14="http://schemas.microsoft.com/office/powerpoint/2010/main" val="387037970"/>
+        <p14:creationId xmlns:p14="http://schemas.microsoft.com/office/powerpoint/2010/main" val="4207120361"/>
       </p:ext>
     </p:extLst>
   </p:cSld>

</xml_diff>